<commit_message>
Revise OSCAR slide: COTS reclassification + Sigma BaSO4 gap
- Amazon & Modernist Pantry moved out of SELECTED-Existing (they are COTS
  purchase channels, not qualified existing suppliers) to SELECTED-New,
  tagged COTS. Existing-Selected now "None".
- Risks: Sigma-Aldrich is R&D-only for FB 28, Proxel BD20 AND barium
  sulfate -> full re-sourcing required. Sigma marked ruled-out in the
  Existing-under-consideration box.

Co-Authored-By: Claude Opus 4.8 <noreply@anthropic.com>
Claude-Session: https://claude.ai/code/session_01EZRavZcQrNpYqhmgv15yRY
</commit_message>
<xml_diff>
--- a/commercial-quotes-fb28-barium-sulfate/Supply-Chain-Strategy-OSCAR.pptx
+++ b/commercial-quotes-fb28-barium-sulfate/Supply-Chain-Strategy-OSCAR.pptx
@@ -502,7 +502,7 @@
           <a:p>
             <a:r>
               <a:rPr lang="en-US" dirty="0"/>
-              <a:t>Existing vs New split is inferred: Amazon/Modernist Pantry treated as existing (already-used retail sources for gelatin &amp; alginate); Sigma-Aldrich treated as existing (broadline). All project-sourced production suppliers treated as new to ATM. Adjust as needed. Data as of Aug 2026.</a:t>
+              <a:t>Amazon &amp; Modernist Pantry are COTS (current purchase channels for gelatin &amp; alginate), not qualified existing suppliers — listed under Selected-New/COTS. No pre-qualified ATM existing supplier for these materials. Sigma-Aldrich ruled out for production (R&amp;D-only for FB 28, Proxel BD20 and barium sulfate). Data as of Aug 2026.</a:t>
             </a:r>
             <a:endParaRPr lang="en-US" dirty="0"/>
           </a:p>
@@ -972,21 +972,6 @@
             <a:endParaRPr lang="en-US" sz="1500" dirty="0"/>
           </a:p>
           <a:p>
-            <a:pPr algn="l" lvl="1" marL="355600" indent="-177800">
-              <a:buSzPct val="100000"/>
-              <a:buChar char="•"/>
-            </a:pPr>
-            <a:r>
-              <a:rPr lang="en-US" sz="1150" b="1" dirty="0">
-                <a:solidFill>
-                  <a:srgbClr val="1F2937"/>
-                </a:solidFill>
-                <a:latin typeface="Arial" pitchFamily="34" charset="0"/>
-                <a:ea typeface="Arial" pitchFamily="34" charset="-122"/>
-                <a:cs typeface="Arial" pitchFamily="34" charset="-120"/>
-              </a:rPr>
-              <a:t>Amazon</a:t>
-            </a:r>
             <a:pPr algn="l" indent="0" marL="0">
               <a:spcAft>
                 <a:spcPts val="600"/>
@@ -994,50 +979,15 @@
               <a:buNone/>
             </a:pPr>
             <a:r>
-              <a:rPr lang="en-US" sz="1150" dirty="0">
-                <a:solidFill>
-                  <a:srgbClr val="44546A"/>
-                </a:solidFill>
-                <a:latin typeface="Arial" pitchFamily="34" charset="0"/>
-                <a:ea typeface="Arial" pitchFamily="34" charset="-122"/>
-                <a:cs typeface="Arial" pitchFamily="34" charset="-120"/>
-              </a:rPr>
-              <a:t> – Fish gelatin &amp; sodium alginate (retail, in-stock)</a:t>
-            </a:r>
-            <a:endParaRPr lang="en-US" sz="1500" dirty="0"/>
-          </a:p>
-          <a:p>
-            <a:pPr algn="l" lvl="1" marL="355600" indent="-177800">
-              <a:buSzPct val="100000"/>
-              <a:buChar char="•"/>
-            </a:pPr>
-            <a:r>
-              <a:rPr lang="en-US" sz="1150" b="1" dirty="0">
-                <a:solidFill>
-                  <a:srgbClr val="1F2937"/>
-                </a:solidFill>
-                <a:latin typeface="Arial" pitchFamily="34" charset="0"/>
-                <a:ea typeface="Arial" pitchFamily="34" charset="-122"/>
-                <a:cs typeface="Arial" pitchFamily="34" charset="-120"/>
-              </a:rPr>
-              <a:t>Modernist Pantry</a:t>
-            </a:r>
-            <a:pPr algn="l" indent="0" marL="0">
-              <a:spcAft>
-                <a:spcPts val="600"/>
-              </a:spcAft>
-              <a:buNone/>
-            </a:pPr>
-            <a:r>
-              <a:rPr lang="en-US" sz="1150" dirty="0">
-                <a:solidFill>
-                  <a:srgbClr val="44546A"/>
-                </a:solidFill>
-                <a:latin typeface="Arial" pitchFamily="34" charset="0"/>
-                <a:ea typeface="Arial" pitchFamily="34" charset="-122"/>
-                <a:cs typeface="Arial" pitchFamily="34" charset="-120"/>
-              </a:rPr>
-              <a:t> – Fish gelatin &amp; sodium alginate (2nd source)</a:t>
+              <a:rPr lang="en-US" sz="1150" i="1" dirty="0">
+                <a:solidFill>
+                  <a:srgbClr val="7A7A7A"/>
+                </a:solidFill>
+                <a:latin typeface="Arial" pitchFamily="34" charset="0"/>
+                <a:ea typeface="Arial" pitchFamily="34" charset="-122"/>
+                <a:cs typeface="Arial" pitchFamily="34" charset="-120"/>
+              </a:rPr>
+              <a:t>None — no pre-qualified ATM supplier for these ION LUNG materials (all sourcing is new; see New / COTS).</a:t>
             </a:r>
             <a:endParaRPr lang="en-US" sz="1500" dirty="0"/>
           </a:p>
@@ -1051,8 +1001,8 @@
         </p:nvSpPr>
         <p:spPr>
           <a:xfrm>
-            <a:off x="457200" y="3063240"/>
-            <a:ext cx="3703320" cy="3566160"/>
+            <a:off x="457200" y="2880360"/>
+            <a:ext cx="3703320" cy="3749040"/>
           </a:xfrm>
           <a:prstGeom prst="rect">
             <a:avLst/>
@@ -1185,6 +1135,76 @@
                 <a:cs typeface="Arial" pitchFamily="34" charset="-120"/>
               </a:rPr>
               <a:t> – Barium sulfate, precipitated (in stock, 2 lb)</a:t>
+            </a:r>
+            <a:endParaRPr lang="en-US" sz="1500" dirty="0"/>
+          </a:p>
+          <a:p>
+            <a:pPr algn="l" lvl="1" marL="355600" indent="-177800">
+              <a:buSzPct val="100000"/>
+              <a:buChar char="•"/>
+            </a:pPr>
+            <a:r>
+              <a:rPr lang="en-US" sz="1150" b="1" dirty="0">
+                <a:solidFill>
+                  <a:srgbClr val="1F2937"/>
+                </a:solidFill>
+                <a:latin typeface="Arial" pitchFamily="34" charset="0"/>
+                <a:ea typeface="Arial" pitchFamily="34" charset="-122"/>
+                <a:cs typeface="Arial" pitchFamily="34" charset="-120"/>
+              </a:rPr>
+              <a:t>Amazon (COTS)</a:t>
+            </a:r>
+            <a:pPr algn="l" indent="0" marL="0">
+              <a:spcAft>
+                <a:spcPts val="600"/>
+              </a:spcAft>
+              <a:buNone/>
+            </a:pPr>
+            <a:r>
+              <a:rPr lang="en-US" sz="1150" dirty="0">
+                <a:solidFill>
+                  <a:srgbClr val="44546A"/>
+                </a:solidFill>
+                <a:latin typeface="Arial" pitchFamily="34" charset="0"/>
+                <a:ea typeface="Arial" pitchFamily="34" charset="-122"/>
+                <a:cs typeface="Arial" pitchFamily="34" charset="-120"/>
+              </a:rPr>
+              <a:t> – Fish gelatin &amp; sodium alginate — current purchase channel</a:t>
+            </a:r>
+            <a:endParaRPr lang="en-US" sz="1500" dirty="0"/>
+          </a:p>
+          <a:p>
+            <a:pPr algn="l" lvl="1" marL="355600" indent="-177800">
+              <a:buSzPct val="100000"/>
+              <a:buChar char="•"/>
+            </a:pPr>
+            <a:r>
+              <a:rPr lang="en-US" sz="1150" b="1" dirty="0">
+                <a:solidFill>
+                  <a:srgbClr val="1F2937"/>
+                </a:solidFill>
+                <a:latin typeface="Arial" pitchFamily="34" charset="0"/>
+                <a:ea typeface="Arial" pitchFamily="34" charset="-122"/>
+                <a:cs typeface="Arial" pitchFamily="34" charset="-120"/>
+              </a:rPr>
+              <a:t>Modernist Pantry (COTS)</a:t>
+            </a:r>
+            <a:pPr algn="l" indent="0" marL="0">
+              <a:spcAft>
+                <a:spcPts val="600"/>
+              </a:spcAft>
+              <a:buNone/>
+            </a:pPr>
+            <a:r>
+              <a:rPr lang="en-US" sz="1150" dirty="0">
+                <a:solidFill>
+                  <a:srgbClr val="44546A"/>
+                </a:solidFill>
+                <a:latin typeface="Arial" pitchFamily="34" charset="0"/>
+                <a:ea typeface="Arial" pitchFamily="34" charset="-122"/>
+                <a:cs typeface="Arial" pitchFamily="34" charset="-120"/>
+              </a:rPr>
+              <a:t> – Fish gelatin &amp; sodium alginate — current purchase channel</a:t>
             </a:r>
             <a:endParaRPr lang="en-US" sz="1500" dirty="0"/>
           </a:p>
@@ -1238,7 +1258,7 @@
             <a:r>
               <a:rPr lang="en-US" sz="1150" b="1" dirty="0">
                 <a:solidFill>
-                  <a:srgbClr val="1F2937"/>
+                  <a:srgbClr val="9C2A00"/>
                 </a:solidFill>
                 <a:latin typeface="Arial" pitchFamily="34" charset="0"/>
                 <a:ea typeface="Arial" pitchFamily="34" charset="-122"/>
@@ -1261,7 +1281,7 @@
                 <a:ea typeface="Arial" pitchFamily="34" charset="-122"/>
                 <a:cs typeface="Arial" pitchFamily="34" charset="-120"/>
               </a:rPr>
-              <a:t> – Barium sulfate (intended primary); commercial-use letter or commercial product pending. FB 28 &amp; Proxel BD20 = R&amp;D-only, not viable for production.</a:t>
+              <a:t> – Ruled out for production: now R&amp;D-only for FB 28, Proxel BD20 AND barium sulfate (see Risks).</a:t>
             </a:r>
             <a:endParaRPr lang="en-US" sz="1500" dirty="0"/>
           </a:p>
@@ -1573,7 +1593,7 @@
                 <a:ea typeface="Arial" pitchFamily="34" charset="-122"/>
                 <a:cs typeface="Arial" pitchFamily="34" charset="-120"/>
               </a:rPr>
-              <a:t>Single / limited source:</a:t>
+              <a:t>Primary supplier gap:</a:t>
             </a:r>
             <a:pPr algn="l" indent="0" marL="0">
               <a:spcAft>
@@ -1590,7 +1610,7 @@
                 <a:ea typeface="Arial" pitchFamily="34" charset="-122"/>
                 <a:cs typeface="Arial" pitchFamily="34" charset="-120"/>
               </a:rPr>
-              <a:t> FB 28 disodium — few US production makers (Koch Color the cleanest exact match).</a:t>
+              <a:t> Sigma-Aldrich (intended primary) is R&amp;D-only for FB 28, Proxel BD20 AND barium sulfate → full re-sourcing required.</a:t>
             </a:r>
             <a:endParaRPr lang="en-US" sz="1500" dirty="0"/>
           </a:p>
@@ -1608,7 +1628,7 @@
                 <a:ea typeface="Arial" pitchFamily="34" charset="-122"/>
                 <a:cs typeface="Arial" pitchFamily="34" charset="-120"/>
               </a:rPr>
-              <a:t>Primary supplier gap:</a:t>
+              <a:t>Single / limited source:</a:t>
             </a:r>
             <a:pPr algn="l" indent="0" marL="0">
               <a:spcAft>
@@ -1625,7 +1645,7 @@
                 <a:ea typeface="Arial" pitchFamily="34" charset="-122"/>
                 <a:cs typeface="Arial" pitchFamily="34" charset="-120"/>
               </a:rPr>
-              <a:t> Sigma-Aldrich (intended primary) is R&amp;D-only for FB 28 &amp; Proxel BD20 → re-sourcing required.</a:t>
+              <a:t> FB 28 disodium — few US production makers (Koch Color the cleanest exact match).</a:t>
             </a:r>
             <a:endParaRPr lang="en-US" sz="1500" dirty="0"/>
           </a:p>

</xml_diff>